<commit_message>
Update API key resolution for Streamlit Cloud secrets
</commit_message>
<xml_diff>
--- a/AI_Tutor_Capstone_Presentation.pptx
+++ b/AI_Tutor_Capstone_Presentation.pptx
@@ -14,6 +14,7 @@
     <p:sldId id="262" r:id="rId13"/>
     <p:sldId id="263" r:id="rId14"/>
     <p:sldId id="264" r:id="rId15"/>
+    <p:sldId id="265" r:id="rId16"/>
   </p:sldIdLst>
   <p:sldSz cx="12191695" cy="6858000" type="screen4x3"/>
   <p:notesSz cx="6858000" cy="9144000"/>
@@ -3092,7 +3093,7 @@
     <p:bg>
       <p:bgPr>
         <a:solidFill>
-          <a:srgbClr val="0B0F17"/>
+          <a:srgbClr val="0D1117"/>
         </a:solidFill>
         <a:effectLst/>
       </p:bgPr>
@@ -3119,11 +3120,11 @@
             <a:avLst/>
           </a:prstGeom>
           <a:solidFill>
-            <a:srgbClr val="0F172A"/>
+            <a:srgbClr val="161B22"/>
           </a:solidFill>
           <a:ln w="12700">
             <a:solidFill>
-              <a:srgbClr val="1E293B"/>
+              <a:srgbClr val="21262D"/>
             </a:solidFill>
           </a:ln>
         </p:spPr>
@@ -3164,7 +3165,7 @@
             <a:avLst/>
           </a:prstGeom>
           <a:solidFill>
-            <a:srgbClr val="0EA5E9"/>
+            <a:srgbClr val="10B981"/>
           </a:solidFill>
           <a:ln>
             <a:noFill/>
@@ -3220,7 +3221,7 @@
               </a:spcAft>
               <a:defRPr sz="1200" b="1">
                 <a:solidFill>
-                  <a:srgbClr val="38BDF8"/>
+                  <a:srgbClr val="34D399"/>
                 </a:solidFill>
               </a:defRPr>
             </a:pPr>
@@ -3235,7 +3236,7 @@
               </a:spcAft>
               <a:defRPr sz="3000" b="1">
                 <a:solidFill>
-                  <a:srgbClr val="F8FAFC"/>
+                  <a:srgbClr val="F0F6FC"/>
                 </a:solidFill>
               </a:defRPr>
             </a:pPr>
@@ -3254,7 +3255,7 @@
               </a:spcAft>
               <a:defRPr sz="1400">
                 <a:solidFill>
-                  <a:srgbClr val="94A3B8"/>
+                  <a:srgbClr val="8B949E"/>
                 </a:solidFill>
               </a:defRPr>
             </a:pPr>
@@ -3266,7 +3267,7 @@
             <a:pPr>
               <a:defRPr sz="1200" b="1">
                 <a:solidFill>
-                  <a:srgbClr val="38BDF8"/>
+                  <a:srgbClr val="F59E0B"/>
                 </a:solidFill>
               </a:defRPr>
             </a:pPr>
@@ -3301,13 +3302,243 @@
             <a:pPr>
               <a:defRPr sz="900">
                 <a:solidFill>
-                  <a:srgbClr val="94A3B8"/>
+                  <a:srgbClr val="8B949E"/>
                 </a:solidFill>
                 <a:latin typeface="Arial"/>
               </a:defRPr>
             </a:pPr>
             <a:r>
-              <a:t>AI-Based Personalized Tutor Using RAG for Syllabus-Aligned Learning  |  Slide 1 of 9</a:t>
+              <a:t>AI-Based Personalized Tutor Using RAG for Syllabus-Aligned Learning  |  Slide 1 of 10</a:t>
+            </a:r>
+          </a:p>
+        </p:txBody>
+      </p:sp>
+    </p:spTree>
+  </p:cSld>
+  <p:clrMapOvr>
+    <a:masterClrMapping/>
+  </p:clrMapOvr>
+</p:sld>
+</file>
+
+<file path=ppt/slides/slide10.xml><?xml version="1.0" encoding="utf-8"?>
+<p:sld xmlns:a="http://schemas.openxmlformats.org/drawingml/2006/main" xmlns:p="http://schemas.openxmlformats.org/presentationml/2006/main" xmlns:r="http://schemas.openxmlformats.org/officeDocument/2006/relationships">
+  <p:cSld>
+    <p:bg>
+      <p:bgPr>
+        <a:solidFill>
+          <a:srgbClr val="0D1117"/>
+        </a:solidFill>
+        <a:effectLst/>
+      </p:bgPr>
+    </p:bg>
+    <p:spTree>
+      <p:nvGrpSpPr>
+        <p:cNvPr id="1" name=""/>
+        <p:cNvGrpSpPr/>
+        <p:nvPr/>
+      </p:nvGrpSpPr>
+      <p:grpSpPr/>
+      <p:sp>
+        <p:nvSpPr>
+          <p:cNvPr id="2" name="Rounded Rectangle 1"/>
+          <p:cNvSpPr/>
+          <p:nvPr/>
+        </p:nvSpPr>
+        <p:spPr>
+          <a:xfrm>
+            <a:off x="1371600" y="1097280"/>
+            <a:ext cx="9448495" cy="4663440"/>
+          </a:xfrm>
+          <a:prstGeom prst="roundRect">
+            <a:avLst/>
+          </a:prstGeom>
+          <a:solidFill>
+            <a:srgbClr val="161B22"/>
+          </a:solidFill>
+          <a:ln w="12700">
+            <a:solidFill>
+              <a:srgbClr val="21262D"/>
+            </a:solidFill>
+          </a:ln>
+        </p:spPr>
+        <p:style>
+          <a:lnRef idx="1">
+            <a:schemeClr val="accent1"/>
+          </a:lnRef>
+          <a:fillRef idx="3">
+            <a:schemeClr val="accent1"/>
+          </a:fillRef>
+          <a:effectRef idx="2">
+            <a:schemeClr val="accent1"/>
+          </a:effectRef>
+          <a:fontRef idx="minor">
+            <a:schemeClr val="lt1"/>
+          </a:fontRef>
+        </p:style>
+        <p:txBody>
+          <a:bodyPr rtlCol="0" anchor="ctr"/>
+          <a:lstStyle/>
+          <a:p>
+            <a:pPr algn="ctr"/>
+          </a:p>
+        </p:txBody>
+      </p:sp>
+      <p:sp>
+        <p:nvSpPr>
+          <p:cNvPr id="3" name="Rectangle 2"/>
+          <p:cNvSpPr/>
+          <p:nvPr/>
+        </p:nvSpPr>
+        <p:spPr>
+          <a:xfrm>
+            <a:off x="1371600" y="1097280"/>
+            <a:ext cx="9448495" cy="54864"/>
+          </a:xfrm>
+          <a:prstGeom prst="rect">
+            <a:avLst/>
+          </a:prstGeom>
+          <a:solidFill>
+            <a:srgbClr val="10B981"/>
+          </a:solidFill>
+          <a:ln>
+            <a:noFill/>
+          </a:ln>
+        </p:spPr>
+        <p:style>
+          <a:lnRef idx="1">
+            <a:schemeClr val="accent1"/>
+          </a:lnRef>
+          <a:fillRef idx="3">
+            <a:schemeClr val="accent1"/>
+          </a:fillRef>
+          <a:effectRef idx="2">
+            <a:schemeClr val="accent1"/>
+          </a:effectRef>
+          <a:fontRef idx="minor">
+            <a:schemeClr val="lt1"/>
+          </a:fontRef>
+        </p:style>
+        <p:txBody>
+          <a:bodyPr rtlCol="0" anchor="ctr"/>
+          <a:lstStyle/>
+          <a:p>
+            <a:pPr algn="ctr"/>
+          </a:p>
+        </p:txBody>
+      </p:sp>
+      <p:sp>
+        <p:nvSpPr>
+          <p:cNvPr id="4" name="TextBox 3"/>
+          <p:cNvSpPr txBox="1"/>
+          <p:nvPr/>
+        </p:nvSpPr>
+        <p:spPr>
+          <a:xfrm>
+            <a:off x="1645920" y="1463040"/>
+            <a:ext cx="8899855" cy="3931920"/>
+          </a:xfrm>
+          <a:prstGeom prst="rect">
+            <a:avLst/>
+          </a:prstGeom>
+          <a:noFill/>
+        </p:spPr>
+        <p:txBody>
+          <a:bodyPr wrap="square">
+            <a:spAutoFit/>
+          </a:bodyPr>
+          <a:lstStyle/>
+          <a:p>
+            <a:pPr>
+              <a:spcAft>
+                <a:spcPts val="2000"/>
+              </a:spcAft>
+              <a:defRPr sz="1200" b="1">
+                <a:solidFill>
+                  <a:srgbClr val="34D399"/>
+                </a:solidFill>
+              </a:defRPr>
+            </a:pPr>
+            <a:r>
+              <a:t>CAPSTONE PROJECT PRESENTATION</a:t>
+            </a:r>
+          </a:p>
+          <a:p>
+            <a:pPr>
+              <a:spcAft>
+                <a:spcPts val="1400"/>
+              </a:spcAft>
+              <a:defRPr sz="4000" b="1">
+                <a:solidFill>
+                  <a:srgbClr val="F0F6FC"/>
+                </a:solidFill>
+              </a:defRPr>
+            </a:pPr>
+            <a:r>
+              <a:t>THANK YOU!</a:t>
+            </a:r>
+          </a:p>
+          <a:p>
+            <a:pPr>
+              <a:spcAft>
+                <a:spcPts val="2500"/>
+              </a:spcAft>
+              <a:defRPr sz="2000" b="1">
+                <a:solidFill>
+                  <a:srgbClr val="F59E0B"/>
+                </a:solidFill>
+              </a:defRPr>
+            </a:pPr>
+            <a:r>
+              <a:t>Questions &amp; Discussion</a:t>
+            </a:r>
+          </a:p>
+          <a:p>
+            <a:pPr>
+              <a:defRPr sz="1400">
+                <a:solidFill>
+                  <a:srgbClr val="8B949E"/>
+                </a:solidFill>
+              </a:defRPr>
+            </a:pPr>
+            <a:r>
+              <a:t>AI-Based Personalized Tutor Using RAG for Syllabus-Aligned Learning</a:t>
+            </a:r>
+          </a:p>
+        </p:txBody>
+      </p:sp>
+      <p:sp>
+        <p:nvSpPr>
+          <p:cNvPr id="5" name="TextBox 4"/>
+          <p:cNvSpPr txBox="1"/>
+          <p:nvPr/>
+        </p:nvSpPr>
+        <p:spPr>
+          <a:xfrm>
+            <a:off x="731520" y="6309360"/>
+            <a:ext cx="10728655" cy="365760"/>
+          </a:xfrm>
+          <a:prstGeom prst="rect">
+            <a:avLst/>
+          </a:prstGeom>
+          <a:noFill/>
+        </p:spPr>
+        <p:txBody>
+          <a:bodyPr wrap="none">
+            <a:spAutoFit/>
+          </a:bodyPr>
+          <a:lstStyle/>
+          <a:p>
+            <a:pPr>
+              <a:defRPr sz="900">
+                <a:solidFill>
+                  <a:srgbClr val="8B949E"/>
+                </a:solidFill>
+                <a:latin typeface="Arial"/>
+              </a:defRPr>
+            </a:pPr>
+            <a:r>
+              <a:t>AI-Based Personalized Tutor Using RAG for Syllabus-Aligned Learning  |  Slide 10 of 10</a:t>
             </a:r>
           </a:p>
         </p:txBody>
@@ -3326,7 +3557,7 @@
     <p:bg>
       <p:bgPr>
         <a:solidFill>
-          <a:srgbClr val="0B0F17"/>
+          <a:srgbClr val="0D1117"/>
         </a:solidFill>
         <a:effectLst/>
       </p:bgPr>
@@ -3363,13 +3594,13 @@
             <a:pPr>
               <a:defRPr sz="1000" b="1">
                 <a:solidFill>
-                  <a:srgbClr val="38BDF8"/>
+                  <a:srgbClr val="34D399"/>
                 </a:solidFill>
                 <a:latin typeface="Arial"/>
               </a:defRPr>
             </a:pPr>
             <a:r>
-              <a:t>CAPSTONE PROJECT</a:t>
+              <a:t>CAPSTONE PROJECT PRESENTATION</a:t>
             </a:r>
           </a:p>
         </p:txBody>
@@ -3399,7 +3630,7 @@
             <a:pPr>
               <a:defRPr sz="2400" b="1">
                 <a:solidFill>
-                  <a:srgbClr val="F8FAFC"/>
+                  <a:srgbClr val="F0F6FC"/>
                 </a:solidFill>
                 <a:latin typeface="Arial"/>
               </a:defRPr>
@@ -3425,11 +3656,11 @@
             <a:avLst/>
           </a:prstGeom>
           <a:solidFill>
-            <a:srgbClr val="0F172A"/>
+            <a:srgbClr val="161B22"/>
           </a:solidFill>
           <a:ln w="12700">
             <a:solidFill>
-              <a:srgbClr val="1E293B"/>
+              <a:srgbClr val="21262D"/>
             </a:solidFill>
           </a:ln>
         </p:spPr>
@@ -3470,7 +3701,7 @@
             <a:avLst/>
           </a:prstGeom>
           <a:solidFill>
-            <a:srgbClr val="0EA5E9"/>
+            <a:srgbClr val="10B981"/>
           </a:solidFill>
           <a:ln>
             <a:noFill/>
@@ -3523,7 +3754,7 @@
             <a:pPr>
               <a:defRPr sz="1500" b="1">
                 <a:solidFill>
-                  <a:srgbClr val="38BDF8"/>
+                  <a:srgbClr val="34D399"/>
                 </a:solidFill>
                 <a:latin typeface="Arial"/>
               </a:defRPr>
@@ -3563,7 +3794,7 @@
               </a:spcAft>
               <a:defRPr sz="1100">
                 <a:solidFill>
-                  <a:srgbClr val="F8FAFC"/>
+                  <a:srgbClr val="F0F6FC"/>
                 </a:solidFill>
               </a:defRPr>
             </a:pPr>
@@ -3578,7 +3809,7 @@
               </a:spcAft>
               <a:defRPr sz="1100">
                 <a:solidFill>
-                  <a:srgbClr val="F8FAFC"/>
+                  <a:srgbClr val="F0F6FC"/>
                 </a:solidFill>
               </a:defRPr>
             </a:pPr>
@@ -3593,7 +3824,7 @@
               </a:spcAft>
               <a:defRPr sz="1100">
                 <a:solidFill>
-                  <a:srgbClr val="F8FAFC"/>
+                  <a:srgbClr val="F0F6FC"/>
                 </a:solidFill>
               </a:defRPr>
             </a:pPr>
@@ -3608,7 +3839,7 @@
               </a:spcAft>
               <a:defRPr sz="1100">
                 <a:solidFill>
-                  <a:srgbClr val="F8FAFC"/>
+                  <a:srgbClr val="F0F6FC"/>
                 </a:solidFill>
               </a:defRPr>
             </a:pPr>
@@ -3633,11 +3864,11 @@
             <a:avLst/>
           </a:prstGeom>
           <a:solidFill>
-            <a:srgbClr val="0F172A"/>
+            <a:srgbClr val="161B22"/>
           </a:solidFill>
           <a:ln w="12700">
             <a:solidFill>
-              <a:srgbClr val="1E293B"/>
+              <a:srgbClr val="21262D"/>
             </a:solidFill>
           </a:ln>
         </p:spPr>
@@ -3678,7 +3909,7 @@
             <a:avLst/>
           </a:prstGeom>
           <a:solidFill>
-            <a:srgbClr val="0EA5E9"/>
+            <a:srgbClr val="F59E0B"/>
           </a:solidFill>
           <a:ln>
             <a:noFill/>
@@ -3731,7 +3962,7 @@
             <a:pPr>
               <a:defRPr sz="1500" b="1">
                 <a:solidFill>
-                  <a:srgbClr val="38BDF8"/>
+                  <a:srgbClr val="34D399"/>
                 </a:solidFill>
                 <a:latin typeface="Arial"/>
               </a:defRPr>
@@ -3771,7 +4002,7 @@
               </a:spcAft>
               <a:defRPr sz="1100">
                 <a:solidFill>
-                  <a:srgbClr val="F8FAFC"/>
+                  <a:srgbClr val="F0F6FC"/>
                 </a:solidFill>
               </a:defRPr>
             </a:pPr>
@@ -3786,7 +4017,7 @@
               </a:spcAft>
               <a:defRPr sz="1100">
                 <a:solidFill>
-                  <a:srgbClr val="F8FAFC"/>
+                  <a:srgbClr val="F0F6FC"/>
                 </a:solidFill>
               </a:defRPr>
             </a:pPr>
@@ -3801,7 +4032,7 @@
               </a:spcAft>
               <a:defRPr sz="1100">
                 <a:solidFill>
-                  <a:srgbClr val="F8FAFC"/>
+                  <a:srgbClr val="F0F6FC"/>
                 </a:solidFill>
               </a:defRPr>
             </a:pPr>
@@ -3816,7 +4047,7 @@
               </a:spcAft>
               <a:defRPr sz="1100">
                 <a:solidFill>
-                  <a:srgbClr val="F8FAFC"/>
+                  <a:srgbClr val="F0F6FC"/>
                 </a:solidFill>
               </a:defRPr>
             </a:pPr>
@@ -3851,13 +4082,13 @@
             <a:pPr>
               <a:defRPr sz="900">
                 <a:solidFill>
-                  <a:srgbClr val="94A3B8"/>
+                  <a:srgbClr val="8B949E"/>
                 </a:solidFill>
                 <a:latin typeface="Arial"/>
               </a:defRPr>
             </a:pPr>
             <a:r>
-              <a:t>AI-Based Personalized Tutor Using RAG for Syllabus-Aligned Learning  |  Slide 2 of 9</a:t>
+              <a:t>AI-Based Personalized Tutor Using RAG for Syllabus-Aligned Learning  |  Slide 2 of 10</a:t>
             </a:r>
           </a:p>
         </p:txBody>
@@ -3876,7 +4107,7 @@
     <p:bg>
       <p:bgPr>
         <a:solidFill>
-          <a:srgbClr val="0B0F17"/>
+          <a:srgbClr val="0D1117"/>
         </a:solidFill>
         <a:effectLst/>
       </p:bgPr>
@@ -3913,13 +4144,13 @@
             <a:pPr>
               <a:defRPr sz="1000" b="1">
                 <a:solidFill>
-                  <a:srgbClr val="38BDF8"/>
+                  <a:srgbClr val="34D399"/>
                 </a:solidFill>
                 <a:latin typeface="Arial"/>
               </a:defRPr>
             </a:pPr>
             <a:r>
-              <a:t>CAPSTONE PROJECT</a:t>
+              <a:t>CAPSTONE PROJECT PRESENTATION</a:t>
             </a:r>
           </a:p>
         </p:txBody>
@@ -3949,7 +4180,7 @@
             <a:pPr>
               <a:defRPr sz="2400" b="1">
                 <a:solidFill>
-                  <a:srgbClr val="F8FAFC"/>
+                  <a:srgbClr val="F0F6FC"/>
                 </a:solidFill>
                 <a:latin typeface="Arial"/>
               </a:defRPr>
@@ -3975,11 +4206,11 @@
             <a:avLst/>
           </a:prstGeom>
           <a:solidFill>
-            <a:srgbClr val="0F172A"/>
+            <a:srgbClr val="161B22"/>
           </a:solidFill>
           <a:ln w="12700">
             <a:solidFill>
-              <a:srgbClr val="1E293B"/>
+              <a:srgbClr val="21262D"/>
             </a:solidFill>
           </a:ln>
         </p:spPr>
@@ -4020,7 +4251,7 @@
             <a:avLst/>
           </a:prstGeom>
           <a:solidFill>
-            <a:srgbClr val="0EA5E9"/>
+            <a:srgbClr val="10B981"/>
           </a:solidFill>
           <a:ln>
             <a:noFill/>
@@ -4073,7 +4304,7 @@
             <a:pPr>
               <a:defRPr sz="1500" b="1">
                 <a:solidFill>
-                  <a:srgbClr val="38BDF8"/>
+                  <a:srgbClr val="34D399"/>
                 </a:solidFill>
                 <a:latin typeface="Arial"/>
               </a:defRPr>
@@ -4113,7 +4344,7 @@
               </a:spcAft>
               <a:defRPr sz="1100">
                 <a:solidFill>
-                  <a:srgbClr val="F8FAFC"/>
+                  <a:srgbClr val="F0F6FC"/>
                 </a:solidFill>
               </a:defRPr>
             </a:pPr>
@@ -4128,7 +4359,7 @@
               </a:spcAft>
               <a:defRPr sz="1100">
                 <a:solidFill>
-                  <a:srgbClr val="F8FAFC"/>
+                  <a:srgbClr val="F0F6FC"/>
                 </a:solidFill>
               </a:defRPr>
             </a:pPr>
@@ -4143,7 +4374,7 @@
               </a:spcAft>
               <a:defRPr sz="1100">
                 <a:solidFill>
-                  <a:srgbClr val="F8FAFC"/>
+                  <a:srgbClr val="F0F6FC"/>
                 </a:solidFill>
               </a:defRPr>
             </a:pPr>
@@ -4168,11 +4399,11 @@
             <a:avLst/>
           </a:prstGeom>
           <a:solidFill>
-            <a:srgbClr val="0F172A"/>
+            <a:srgbClr val="161B22"/>
           </a:solidFill>
           <a:ln w="12700">
             <a:solidFill>
-              <a:srgbClr val="1E293B"/>
+              <a:srgbClr val="21262D"/>
             </a:solidFill>
           </a:ln>
         </p:spPr>
@@ -4213,7 +4444,7 @@
             <a:avLst/>
           </a:prstGeom>
           <a:solidFill>
-            <a:srgbClr val="0EA5E9"/>
+            <a:srgbClr val="F59E0B"/>
           </a:solidFill>
           <a:ln>
             <a:noFill/>
@@ -4266,7 +4497,7 @@
             <a:pPr>
               <a:defRPr sz="1500" b="1">
                 <a:solidFill>
-                  <a:srgbClr val="38BDF8"/>
+                  <a:srgbClr val="34D399"/>
                 </a:solidFill>
                 <a:latin typeface="Arial"/>
               </a:defRPr>
@@ -4306,7 +4537,7 @@
               </a:spcAft>
               <a:defRPr sz="1100">
                 <a:solidFill>
-                  <a:srgbClr val="F8FAFC"/>
+                  <a:srgbClr val="F0F6FC"/>
                 </a:solidFill>
               </a:defRPr>
             </a:pPr>
@@ -4321,7 +4552,7 @@
               </a:spcAft>
               <a:defRPr sz="1100">
                 <a:solidFill>
-                  <a:srgbClr val="F8FAFC"/>
+                  <a:srgbClr val="F0F6FC"/>
                 </a:solidFill>
               </a:defRPr>
             </a:pPr>
@@ -4336,7 +4567,7 @@
               </a:spcAft>
               <a:defRPr sz="1100">
                 <a:solidFill>
-                  <a:srgbClr val="F8FAFC"/>
+                  <a:srgbClr val="F0F6FC"/>
                 </a:solidFill>
               </a:defRPr>
             </a:pPr>
@@ -4361,11 +4592,11 @@
             <a:avLst/>
           </a:prstGeom>
           <a:solidFill>
-            <a:srgbClr val="0F172A"/>
+            <a:srgbClr val="161B22"/>
           </a:solidFill>
           <a:ln w="12700">
             <a:solidFill>
-              <a:srgbClr val="1E293B"/>
+              <a:srgbClr val="21262D"/>
             </a:solidFill>
           </a:ln>
         </p:spPr>
@@ -4406,7 +4637,7 @@
             <a:avLst/>
           </a:prstGeom>
           <a:solidFill>
-            <a:srgbClr val="0EA5E9"/>
+            <a:srgbClr val="10B981"/>
           </a:solidFill>
           <a:ln>
             <a:noFill/>
@@ -4459,7 +4690,7 @@
             <a:pPr>
               <a:defRPr sz="1500" b="1">
                 <a:solidFill>
-                  <a:srgbClr val="38BDF8"/>
+                  <a:srgbClr val="34D399"/>
                 </a:solidFill>
                 <a:latin typeface="Arial"/>
               </a:defRPr>
@@ -4499,7 +4730,7 @@
               </a:spcAft>
               <a:defRPr sz="1100">
                 <a:solidFill>
-                  <a:srgbClr val="F8FAFC"/>
+                  <a:srgbClr val="F0F6FC"/>
                 </a:solidFill>
               </a:defRPr>
             </a:pPr>
@@ -4514,7 +4745,7 @@
               </a:spcAft>
               <a:defRPr sz="1100">
                 <a:solidFill>
-                  <a:srgbClr val="F8FAFC"/>
+                  <a:srgbClr val="F0F6FC"/>
                 </a:solidFill>
               </a:defRPr>
             </a:pPr>
@@ -4529,7 +4760,7 @@
               </a:spcAft>
               <a:defRPr sz="1100">
                 <a:solidFill>
-                  <a:srgbClr val="F8FAFC"/>
+                  <a:srgbClr val="F0F6FC"/>
                 </a:solidFill>
               </a:defRPr>
             </a:pPr>
@@ -4564,13 +4795,13 @@
             <a:pPr>
               <a:defRPr sz="900">
                 <a:solidFill>
-                  <a:srgbClr val="94A3B8"/>
+                  <a:srgbClr val="8B949E"/>
                 </a:solidFill>
                 <a:latin typeface="Arial"/>
               </a:defRPr>
             </a:pPr>
             <a:r>
-              <a:t>AI-Based Personalized Tutor Using RAG for Syllabus-Aligned Learning  |  Slide 3 of 9</a:t>
+              <a:t>AI-Based Personalized Tutor Using RAG for Syllabus-Aligned Learning  |  Slide 3 of 10</a:t>
             </a:r>
           </a:p>
         </p:txBody>
@@ -4589,7 +4820,7 @@
     <p:bg>
       <p:bgPr>
         <a:solidFill>
-          <a:srgbClr val="0B0F17"/>
+          <a:srgbClr val="0D1117"/>
         </a:solidFill>
         <a:effectLst/>
       </p:bgPr>
@@ -4626,13 +4857,13 @@
             <a:pPr>
               <a:defRPr sz="1000" b="1">
                 <a:solidFill>
-                  <a:srgbClr val="38BDF8"/>
+                  <a:srgbClr val="34D399"/>
                 </a:solidFill>
                 <a:latin typeface="Arial"/>
               </a:defRPr>
             </a:pPr>
             <a:r>
-              <a:t>CAPSTONE PROJECT</a:t>
+              <a:t>CAPSTONE PROJECT PRESENTATION</a:t>
             </a:r>
           </a:p>
         </p:txBody>
@@ -4662,7 +4893,7 @@
             <a:pPr>
               <a:defRPr sz="2400" b="1">
                 <a:solidFill>
-                  <a:srgbClr val="F8FAFC"/>
+                  <a:srgbClr val="F0F6FC"/>
                 </a:solidFill>
                 <a:latin typeface="Arial"/>
               </a:defRPr>
@@ -4688,11 +4919,11 @@
             <a:avLst/>
           </a:prstGeom>
           <a:solidFill>
-            <a:srgbClr val="0F172A"/>
+            <a:srgbClr val="161B22"/>
           </a:solidFill>
           <a:ln w="12700">
             <a:solidFill>
-              <a:srgbClr val="1E293B"/>
+              <a:srgbClr val="21262D"/>
             </a:solidFill>
           </a:ln>
         </p:spPr>
@@ -4733,7 +4964,7 @@
             <a:avLst/>
           </a:prstGeom>
           <a:solidFill>
-            <a:srgbClr val="0EA5E9"/>
+            <a:srgbClr val="10B981"/>
           </a:solidFill>
           <a:ln>
             <a:noFill/>
@@ -4786,7 +5017,7 @@
             <a:pPr>
               <a:defRPr sz="1500" b="1">
                 <a:solidFill>
-                  <a:srgbClr val="38BDF8"/>
+                  <a:srgbClr val="34D399"/>
                 </a:solidFill>
                 <a:latin typeface="Arial"/>
               </a:defRPr>
@@ -4826,7 +5057,7 @@
               </a:spcAft>
               <a:defRPr sz="1000">
                 <a:solidFill>
-                  <a:srgbClr val="F8FAFC"/>
+                  <a:srgbClr val="F0F6FC"/>
                 </a:solidFill>
               </a:defRPr>
             </a:pPr>
@@ -4841,7 +5072,7 @@
               </a:spcAft>
               <a:defRPr sz="1000">
                 <a:solidFill>
-                  <a:srgbClr val="F8FAFC"/>
+                  <a:srgbClr val="F0F6FC"/>
                 </a:solidFill>
               </a:defRPr>
             </a:pPr>
@@ -4856,7 +5087,7 @@
               </a:spcAft>
               <a:defRPr sz="1000">
                 <a:solidFill>
-                  <a:srgbClr val="F8FAFC"/>
+                  <a:srgbClr val="F0F6FC"/>
                 </a:solidFill>
               </a:defRPr>
             </a:pPr>
@@ -4871,7 +5102,7 @@
               </a:spcAft>
               <a:defRPr sz="1000">
                 <a:solidFill>
-                  <a:srgbClr val="F8FAFC"/>
+                  <a:srgbClr val="F0F6FC"/>
                 </a:solidFill>
               </a:defRPr>
             </a:pPr>
@@ -4896,11 +5127,11 @@
             <a:avLst/>
           </a:prstGeom>
           <a:solidFill>
-            <a:srgbClr val="0F172A"/>
+            <a:srgbClr val="161B22"/>
           </a:solidFill>
           <a:ln w="12700">
             <a:solidFill>
-              <a:srgbClr val="1E293B"/>
+              <a:srgbClr val="21262D"/>
             </a:solidFill>
           </a:ln>
         </p:spPr>
@@ -4941,7 +5172,7 @@
             <a:avLst/>
           </a:prstGeom>
           <a:solidFill>
-            <a:srgbClr val="0EA5E9"/>
+            <a:srgbClr val="F59E0B"/>
           </a:solidFill>
           <a:ln>
             <a:noFill/>
@@ -4994,7 +5225,7 @@
             <a:pPr>
               <a:defRPr sz="1500" b="1">
                 <a:solidFill>
-                  <a:srgbClr val="38BDF8"/>
+                  <a:srgbClr val="34D399"/>
                 </a:solidFill>
                 <a:latin typeface="Arial"/>
               </a:defRPr>
@@ -5034,7 +5265,7 @@
               </a:spcAft>
               <a:defRPr sz="1000">
                 <a:solidFill>
-                  <a:srgbClr val="F8FAFC"/>
+                  <a:srgbClr val="F0F6FC"/>
                 </a:solidFill>
               </a:defRPr>
             </a:pPr>
@@ -5049,7 +5280,7 @@
               </a:spcAft>
               <a:defRPr sz="1000">
                 <a:solidFill>
-                  <a:srgbClr val="F8FAFC"/>
+                  <a:srgbClr val="F0F6FC"/>
                 </a:solidFill>
               </a:defRPr>
             </a:pPr>
@@ -5064,7 +5295,7 @@
               </a:spcAft>
               <a:defRPr sz="1000">
                 <a:solidFill>
-                  <a:srgbClr val="F8FAFC"/>
+                  <a:srgbClr val="F0F6FC"/>
                 </a:solidFill>
               </a:defRPr>
             </a:pPr>
@@ -5079,7 +5310,7 @@
               </a:spcAft>
               <a:defRPr sz="1000">
                 <a:solidFill>
-                  <a:srgbClr val="F8FAFC"/>
+                  <a:srgbClr val="F0F6FC"/>
                 </a:solidFill>
               </a:defRPr>
             </a:pPr>
@@ -5114,13 +5345,13 @@
             <a:pPr>
               <a:defRPr sz="900">
                 <a:solidFill>
-                  <a:srgbClr val="94A3B8"/>
+                  <a:srgbClr val="8B949E"/>
                 </a:solidFill>
                 <a:latin typeface="Arial"/>
               </a:defRPr>
             </a:pPr>
             <a:r>
-              <a:t>AI-Based Personalized Tutor Using RAG for Syllabus-Aligned Learning  |  Slide 4 of 9</a:t>
+              <a:t>AI-Based Personalized Tutor Using RAG for Syllabus-Aligned Learning  |  Slide 4 of 10</a:t>
             </a:r>
           </a:p>
         </p:txBody>
@@ -5139,7 +5370,7 @@
     <p:bg>
       <p:bgPr>
         <a:solidFill>
-          <a:srgbClr val="0B0F17"/>
+          <a:srgbClr val="0D1117"/>
         </a:solidFill>
         <a:effectLst/>
       </p:bgPr>
@@ -5176,13 +5407,13 @@
             <a:pPr>
               <a:defRPr sz="1000" b="1">
                 <a:solidFill>
-                  <a:srgbClr val="38BDF8"/>
+                  <a:srgbClr val="34D399"/>
                 </a:solidFill>
                 <a:latin typeface="Arial"/>
               </a:defRPr>
             </a:pPr>
             <a:r>
-              <a:t>CAPSTONE PROJECT</a:t>
+              <a:t>CAPSTONE PROJECT PRESENTATION</a:t>
             </a:r>
           </a:p>
         </p:txBody>
@@ -5212,7 +5443,7 @@
             <a:pPr>
               <a:defRPr sz="2400" b="1">
                 <a:solidFill>
-                  <a:srgbClr val="F8FAFC"/>
+                  <a:srgbClr val="F0F6FC"/>
                 </a:solidFill>
                 <a:latin typeface="Arial"/>
               </a:defRPr>
@@ -5238,11 +5469,11 @@
             <a:avLst/>
           </a:prstGeom>
           <a:solidFill>
-            <a:srgbClr val="0F172A"/>
+            <a:srgbClr val="161B22"/>
           </a:solidFill>
           <a:ln w="12700">
             <a:solidFill>
-              <a:srgbClr val="1E293B"/>
+              <a:srgbClr val="21262D"/>
             </a:solidFill>
           </a:ln>
         </p:spPr>
@@ -5283,7 +5514,7 @@
             <a:avLst/>
           </a:prstGeom>
           <a:solidFill>
-            <a:srgbClr val="0EA5E9"/>
+            <a:srgbClr val="10B981"/>
           </a:solidFill>
           <a:ln>
             <a:noFill/>
@@ -5336,7 +5567,7 @@
             <a:pPr>
               <a:defRPr sz="1500" b="1">
                 <a:solidFill>
-                  <a:srgbClr val="38BDF8"/>
+                  <a:srgbClr val="34D399"/>
                 </a:solidFill>
                 <a:latin typeface="Arial"/>
               </a:defRPr>
@@ -5372,7 +5603,7 @@
             <a:pPr>
               <a:defRPr sz="1100">
                 <a:solidFill>
-                  <a:srgbClr val="F8FAFC"/>
+                  <a:srgbClr val="F0F6FC"/>
                 </a:solidFill>
               </a:defRPr>
             </a:pPr>
@@ -5397,11 +5628,11 @@
             <a:avLst/>
           </a:prstGeom>
           <a:solidFill>
-            <a:srgbClr val="0F172A"/>
+            <a:srgbClr val="161B22"/>
           </a:solidFill>
           <a:ln w="12700">
             <a:solidFill>
-              <a:srgbClr val="1E293B"/>
+              <a:srgbClr val="21262D"/>
             </a:solidFill>
           </a:ln>
         </p:spPr>
@@ -5442,7 +5673,7 @@
             <a:avLst/>
           </a:prstGeom>
           <a:solidFill>
-            <a:srgbClr val="0EA5E9"/>
+            <a:srgbClr val="F59E0B"/>
           </a:solidFill>
           <a:ln>
             <a:noFill/>
@@ -5495,7 +5726,7 @@
             <a:pPr>
               <a:defRPr sz="1500" b="1">
                 <a:solidFill>
-                  <a:srgbClr val="38BDF8"/>
+                  <a:srgbClr val="34D399"/>
                 </a:solidFill>
                 <a:latin typeface="Arial"/>
               </a:defRPr>
@@ -5531,7 +5762,7 @@
             <a:pPr>
               <a:defRPr sz="1100">
                 <a:solidFill>
-                  <a:srgbClr val="F8FAFC"/>
+                  <a:srgbClr val="F0F6FC"/>
                 </a:solidFill>
               </a:defRPr>
             </a:pPr>
@@ -5556,11 +5787,11 @@
             <a:avLst/>
           </a:prstGeom>
           <a:solidFill>
-            <a:srgbClr val="0F172A"/>
+            <a:srgbClr val="161B22"/>
           </a:solidFill>
           <a:ln w="12700">
             <a:solidFill>
-              <a:srgbClr val="1E293B"/>
+              <a:srgbClr val="21262D"/>
             </a:solidFill>
           </a:ln>
         </p:spPr>
@@ -5601,7 +5832,7 @@
             <a:avLst/>
           </a:prstGeom>
           <a:solidFill>
-            <a:srgbClr val="0EA5E9"/>
+            <a:srgbClr val="F59E0B"/>
           </a:solidFill>
           <a:ln>
             <a:noFill/>
@@ -5654,7 +5885,7 @@
             <a:pPr>
               <a:defRPr sz="1500" b="1">
                 <a:solidFill>
-                  <a:srgbClr val="38BDF8"/>
+                  <a:srgbClr val="34D399"/>
                 </a:solidFill>
                 <a:latin typeface="Arial"/>
               </a:defRPr>
@@ -5690,7 +5921,7 @@
             <a:pPr>
               <a:defRPr sz="1100">
                 <a:solidFill>
-                  <a:srgbClr val="F8FAFC"/>
+                  <a:srgbClr val="F0F6FC"/>
                 </a:solidFill>
               </a:defRPr>
             </a:pPr>
@@ -5715,11 +5946,11 @@
             <a:avLst/>
           </a:prstGeom>
           <a:solidFill>
-            <a:srgbClr val="0F172A"/>
+            <a:srgbClr val="161B22"/>
           </a:solidFill>
           <a:ln w="12700">
             <a:solidFill>
-              <a:srgbClr val="1E293B"/>
+              <a:srgbClr val="21262D"/>
             </a:solidFill>
           </a:ln>
         </p:spPr>
@@ -5760,7 +5991,7 @@
             <a:avLst/>
           </a:prstGeom>
           <a:solidFill>
-            <a:srgbClr val="0EA5E9"/>
+            <a:srgbClr val="10B981"/>
           </a:solidFill>
           <a:ln>
             <a:noFill/>
@@ -5813,7 +6044,7 @@
             <a:pPr>
               <a:defRPr sz="1500" b="1">
                 <a:solidFill>
-                  <a:srgbClr val="38BDF8"/>
+                  <a:srgbClr val="34D399"/>
                 </a:solidFill>
                 <a:latin typeface="Arial"/>
               </a:defRPr>
@@ -5849,7 +6080,7 @@
             <a:pPr>
               <a:defRPr sz="1100">
                 <a:solidFill>
-                  <a:srgbClr val="F8FAFC"/>
+                  <a:srgbClr val="F0F6FC"/>
                 </a:solidFill>
               </a:defRPr>
             </a:pPr>
@@ -5884,13 +6115,13 @@
             <a:pPr>
               <a:defRPr sz="900">
                 <a:solidFill>
-                  <a:srgbClr val="94A3B8"/>
+                  <a:srgbClr val="8B949E"/>
                 </a:solidFill>
                 <a:latin typeface="Arial"/>
               </a:defRPr>
             </a:pPr>
             <a:r>
-              <a:t>AI-Based Personalized Tutor Using RAG for Syllabus-Aligned Learning  |  Slide 5 of 9</a:t>
+              <a:t>AI-Based Personalized Tutor Using RAG for Syllabus-Aligned Learning  |  Slide 5 of 10</a:t>
             </a:r>
           </a:p>
         </p:txBody>
@@ -5909,7 +6140,7 @@
     <p:bg>
       <p:bgPr>
         <a:solidFill>
-          <a:srgbClr val="0B0F17"/>
+          <a:srgbClr val="0D1117"/>
         </a:solidFill>
         <a:effectLst/>
       </p:bgPr>
@@ -5946,13 +6177,13 @@
             <a:pPr>
               <a:defRPr sz="1000" b="1">
                 <a:solidFill>
-                  <a:srgbClr val="38BDF8"/>
+                  <a:srgbClr val="34D399"/>
                 </a:solidFill>
                 <a:latin typeface="Arial"/>
               </a:defRPr>
             </a:pPr>
             <a:r>
-              <a:t>CAPSTONE PROJECT</a:t>
+              <a:t>CAPSTONE PROJECT PRESENTATION</a:t>
             </a:r>
           </a:p>
         </p:txBody>
@@ -5982,7 +6213,7 @@
             <a:pPr>
               <a:defRPr sz="2400" b="1">
                 <a:solidFill>
-                  <a:srgbClr val="F8FAFC"/>
+                  <a:srgbClr val="F0F6FC"/>
                 </a:solidFill>
                 <a:latin typeface="Arial"/>
               </a:defRPr>
@@ -6032,11 +6263,11 @@
             <a:avLst/>
           </a:prstGeom>
           <a:solidFill>
-            <a:srgbClr val="0F172A"/>
+            <a:srgbClr val="161B22"/>
           </a:solidFill>
           <a:ln w="12700">
             <a:solidFill>
-              <a:srgbClr val="1E293B"/>
+              <a:srgbClr val="21262D"/>
             </a:solidFill>
           </a:ln>
         </p:spPr>
@@ -6077,7 +6308,7 @@
             <a:avLst/>
           </a:prstGeom>
           <a:solidFill>
-            <a:srgbClr val="0EA5E9"/>
+            <a:srgbClr val="10B981"/>
           </a:solidFill>
           <a:ln>
             <a:noFill/>
@@ -6130,7 +6361,7 @@
             <a:pPr>
               <a:defRPr sz="1500" b="1">
                 <a:solidFill>
-                  <a:srgbClr val="38BDF8"/>
+                  <a:srgbClr val="34D399"/>
                 </a:solidFill>
                 <a:latin typeface="Arial"/>
               </a:defRPr>
@@ -6170,12 +6401,12 @@
               </a:spcAft>
               <a:defRPr sz="1000">
                 <a:solidFill>
-                  <a:srgbClr val="F8FAFC"/>
-                </a:solidFill>
-              </a:defRPr>
-            </a:pPr>
-            <a:r>
-              <a:t>• Visual Excellence: Executive dark slate design system with crisp typography and responsive metric cards.</a:t>
+                  <a:srgbClr val="F0F6FC"/>
+                </a:solidFill>
+              </a:defRPr>
+            </a:pPr>
+            <a:r>
+              <a:t>• Visual Excellence: Executive dark charcoal design system with Emerald Teal typography and responsive metric cards.</a:t>
             </a:r>
           </a:p>
           <a:p>
@@ -6185,7 +6416,7 @@
               </a:spcAft>
               <a:defRPr sz="1000">
                 <a:solidFill>
-                  <a:srgbClr val="F8FAFC"/>
+                  <a:srgbClr val="F0F6FC"/>
                 </a:solidFill>
               </a:defRPr>
             </a:pPr>
@@ -6200,7 +6431,7 @@
               </a:spcAft>
               <a:defRPr sz="1000">
                 <a:solidFill>
-                  <a:srgbClr val="F8FAFC"/>
+                  <a:srgbClr val="F0F6FC"/>
                 </a:solidFill>
               </a:defRPr>
             </a:pPr>
@@ -6215,7 +6446,7 @@
               </a:spcAft>
               <a:defRPr sz="1000">
                 <a:solidFill>
-                  <a:srgbClr val="F8FAFC"/>
+                  <a:srgbClr val="F0F6FC"/>
                 </a:solidFill>
               </a:defRPr>
             </a:pPr>
@@ -6230,7 +6461,7 @@
               </a:spcAft>
               <a:defRPr sz="1000">
                 <a:solidFill>
-                  <a:srgbClr val="F8FAFC"/>
+                  <a:srgbClr val="F0F6FC"/>
                 </a:solidFill>
               </a:defRPr>
             </a:pPr>
@@ -6265,13 +6496,13 @@
             <a:pPr>
               <a:defRPr sz="900">
                 <a:solidFill>
-                  <a:srgbClr val="94A3B8"/>
+                  <a:srgbClr val="8B949E"/>
                 </a:solidFill>
                 <a:latin typeface="Arial"/>
               </a:defRPr>
             </a:pPr>
             <a:r>
-              <a:t>AI-Based Personalized Tutor Using RAG for Syllabus-Aligned Learning  |  Slide 6 of 9</a:t>
+              <a:t>AI-Based Personalized Tutor Using RAG for Syllabus-Aligned Learning  |  Slide 6 of 10</a:t>
             </a:r>
           </a:p>
         </p:txBody>
@@ -6290,7 +6521,7 @@
     <p:bg>
       <p:bgPr>
         <a:solidFill>
-          <a:srgbClr val="0B0F17"/>
+          <a:srgbClr val="0D1117"/>
         </a:solidFill>
         <a:effectLst/>
       </p:bgPr>
@@ -6327,13 +6558,13 @@
             <a:pPr>
               <a:defRPr sz="1000" b="1">
                 <a:solidFill>
-                  <a:srgbClr val="38BDF8"/>
+                  <a:srgbClr val="34D399"/>
                 </a:solidFill>
                 <a:latin typeface="Arial"/>
               </a:defRPr>
             </a:pPr>
             <a:r>
-              <a:t>CAPSTONE PROJECT</a:t>
+              <a:t>CAPSTONE PROJECT PRESENTATION</a:t>
             </a:r>
           </a:p>
         </p:txBody>
@@ -6363,7 +6594,7 @@
             <a:pPr>
               <a:defRPr sz="2400" b="1">
                 <a:solidFill>
-                  <a:srgbClr val="F8FAFC"/>
+                  <a:srgbClr val="F0F6FC"/>
                 </a:solidFill>
                 <a:latin typeface="Arial"/>
               </a:defRPr>
@@ -6389,11 +6620,11 @@
             <a:avLst/>
           </a:prstGeom>
           <a:solidFill>
-            <a:srgbClr val="0F172A"/>
+            <a:srgbClr val="161B22"/>
           </a:solidFill>
           <a:ln w="12700">
             <a:solidFill>
-              <a:srgbClr val="1E293B"/>
+              <a:srgbClr val="21262D"/>
             </a:solidFill>
           </a:ln>
         </p:spPr>
@@ -6434,7 +6665,7 @@
             <a:avLst/>
           </a:prstGeom>
           <a:solidFill>
-            <a:srgbClr val="0EA5E9"/>
+            <a:srgbClr val="10B981"/>
           </a:solidFill>
           <a:ln>
             <a:noFill/>
@@ -6487,7 +6718,7 @@
             <a:pPr>
               <a:defRPr sz="1500" b="1">
                 <a:solidFill>
-                  <a:srgbClr val="38BDF8"/>
+                  <a:srgbClr val="34D399"/>
                 </a:solidFill>
                 <a:latin typeface="Arial"/>
               </a:defRPr>
@@ -6527,7 +6758,7 @@
               </a:spcAft>
               <a:defRPr sz="1100">
                 <a:solidFill>
-                  <a:srgbClr val="F8FAFC"/>
+                  <a:srgbClr val="F0F6FC"/>
                 </a:solidFill>
               </a:defRPr>
             </a:pPr>
@@ -6542,7 +6773,7 @@
               </a:spcAft>
               <a:defRPr sz="1100">
                 <a:solidFill>
-                  <a:srgbClr val="F8FAFC"/>
+                  <a:srgbClr val="F0F6FC"/>
                 </a:solidFill>
               </a:defRPr>
             </a:pPr>
@@ -6557,7 +6788,7 @@
               </a:spcAft>
               <a:defRPr sz="1100">
                 <a:solidFill>
-                  <a:srgbClr val="F8FAFC"/>
+                  <a:srgbClr val="F0F6FC"/>
                 </a:solidFill>
               </a:defRPr>
             </a:pPr>
@@ -6582,11 +6813,11 @@
             <a:avLst/>
           </a:prstGeom>
           <a:solidFill>
-            <a:srgbClr val="0F172A"/>
+            <a:srgbClr val="161B22"/>
           </a:solidFill>
           <a:ln w="12700">
             <a:solidFill>
-              <a:srgbClr val="1E293B"/>
+              <a:srgbClr val="21262D"/>
             </a:solidFill>
           </a:ln>
         </p:spPr>
@@ -6627,7 +6858,7 @@
             <a:avLst/>
           </a:prstGeom>
           <a:solidFill>
-            <a:srgbClr val="0EA5E9"/>
+            <a:srgbClr val="F59E0B"/>
           </a:solidFill>
           <a:ln>
             <a:noFill/>
@@ -6680,7 +6911,7 @@
             <a:pPr>
               <a:defRPr sz="1500" b="1">
                 <a:solidFill>
-                  <a:srgbClr val="38BDF8"/>
+                  <a:srgbClr val="34D399"/>
                 </a:solidFill>
                 <a:latin typeface="Arial"/>
               </a:defRPr>
@@ -6720,7 +6951,7 @@
               </a:spcAft>
               <a:defRPr sz="1100">
                 <a:solidFill>
-                  <a:srgbClr val="F8FAFC"/>
+                  <a:srgbClr val="F0F6FC"/>
                 </a:solidFill>
               </a:defRPr>
             </a:pPr>
@@ -6735,7 +6966,7 @@
               </a:spcAft>
               <a:defRPr sz="1100">
                 <a:solidFill>
-                  <a:srgbClr val="F8FAFC"/>
+                  <a:srgbClr val="F0F6FC"/>
                 </a:solidFill>
               </a:defRPr>
             </a:pPr>
@@ -6750,7 +6981,7 @@
               </a:spcAft>
               <a:defRPr sz="1100">
                 <a:solidFill>
-                  <a:srgbClr val="F8FAFC"/>
+                  <a:srgbClr val="F0F6FC"/>
                 </a:solidFill>
               </a:defRPr>
             </a:pPr>
@@ -6775,11 +7006,11 @@
             <a:avLst/>
           </a:prstGeom>
           <a:solidFill>
-            <a:srgbClr val="0F172A"/>
+            <a:srgbClr val="161B22"/>
           </a:solidFill>
           <a:ln w="12700">
             <a:solidFill>
-              <a:srgbClr val="1E293B"/>
+              <a:srgbClr val="21262D"/>
             </a:solidFill>
           </a:ln>
         </p:spPr>
@@ -6820,7 +7051,7 @@
             <a:avLst/>
           </a:prstGeom>
           <a:solidFill>
-            <a:srgbClr val="0EA5E9"/>
+            <a:srgbClr val="10B981"/>
           </a:solidFill>
           <a:ln>
             <a:noFill/>
@@ -6873,7 +7104,7 @@
             <a:pPr>
               <a:defRPr sz="1500" b="1">
                 <a:solidFill>
-                  <a:srgbClr val="38BDF8"/>
+                  <a:srgbClr val="34D399"/>
                 </a:solidFill>
                 <a:latin typeface="Arial"/>
               </a:defRPr>
@@ -6913,7 +7144,7 @@
               </a:spcAft>
               <a:defRPr sz="1100">
                 <a:solidFill>
-                  <a:srgbClr val="F8FAFC"/>
+                  <a:srgbClr val="F0F6FC"/>
                 </a:solidFill>
               </a:defRPr>
             </a:pPr>
@@ -6928,7 +7159,7 @@
               </a:spcAft>
               <a:defRPr sz="1100">
                 <a:solidFill>
-                  <a:srgbClr val="F8FAFC"/>
+                  <a:srgbClr val="F0F6FC"/>
                 </a:solidFill>
               </a:defRPr>
             </a:pPr>
@@ -6943,7 +7174,7 @@
               </a:spcAft>
               <a:defRPr sz="1100">
                 <a:solidFill>
-                  <a:srgbClr val="F8FAFC"/>
+                  <a:srgbClr val="F0F6FC"/>
                 </a:solidFill>
               </a:defRPr>
             </a:pPr>
@@ -6978,13 +7209,13 @@
             <a:pPr>
               <a:defRPr sz="900">
                 <a:solidFill>
-                  <a:srgbClr val="94A3B8"/>
+                  <a:srgbClr val="8B949E"/>
                 </a:solidFill>
                 <a:latin typeface="Arial"/>
               </a:defRPr>
             </a:pPr>
             <a:r>
-              <a:t>AI-Based Personalized Tutor Using RAG for Syllabus-Aligned Learning  |  Slide 7 of 9</a:t>
+              <a:t>AI-Based Personalized Tutor Using RAG for Syllabus-Aligned Learning  |  Slide 7 of 10</a:t>
             </a:r>
           </a:p>
         </p:txBody>
@@ -7003,7 +7234,7 @@
     <p:bg>
       <p:bgPr>
         <a:solidFill>
-          <a:srgbClr val="0B0F17"/>
+          <a:srgbClr val="0D1117"/>
         </a:solidFill>
         <a:effectLst/>
       </p:bgPr>
@@ -7040,13 +7271,13 @@
             <a:pPr>
               <a:defRPr sz="1000" b="1">
                 <a:solidFill>
-                  <a:srgbClr val="38BDF8"/>
+                  <a:srgbClr val="34D399"/>
                 </a:solidFill>
                 <a:latin typeface="Arial"/>
               </a:defRPr>
             </a:pPr>
             <a:r>
-              <a:t>CAPSTONE PROJECT</a:t>
+              <a:t>CAPSTONE PROJECT PRESENTATION</a:t>
             </a:r>
           </a:p>
         </p:txBody>
@@ -7076,7 +7307,7 @@
             <a:pPr>
               <a:defRPr sz="2400" b="1">
                 <a:solidFill>
-                  <a:srgbClr val="F8FAFC"/>
+                  <a:srgbClr val="F0F6FC"/>
                 </a:solidFill>
                 <a:latin typeface="Arial"/>
               </a:defRPr>
@@ -7102,11 +7333,11 @@
             <a:avLst/>
           </a:prstGeom>
           <a:solidFill>
-            <a:srgbClr val="0F172A"/>
+            <a:srgbClr val="161B22"/>
           </a:solidFill>
           <a:ln w="12700">
             <a:solidFill>
-              <a:srgbClr val="1E293B"/>
+              <a:srgbClr val="21262D"/>
             </a:solidFill>
           </a:ln>
         </p:spPr>
@@ -7147,7 +7378,7 @@
             <a:avLst/>
           </a:prstGeom>
           <a:solidFill>
-            <a:srgbClr val="0EA5E9"/>
+            <a:srgbClr val="10B981"/>
           </a:solidFill>
           <a:ln>
             <a:noFill/>
@@ -7200,7 +7431,7 @@
             <a:pPr>
               <a:defRPr sz="1500" b="1">
                 <a:solidFill>
-                  <a:srgbClr val="38BDF8"/>
+                  <a:srgbClr val="34D399"/>
                 </a:solidFill>
                 <a:latin typeface="Arial"/>
               </a:defRPr>
@@ -7236,7 +7467,7 @@
             <a:pPr>
               <a:defRPr sz="1100">
                 <a:solidFill>
-                  <a:srgbClr val="F8FAFC"/>
+                  <a:srgbClr val="F0F6FC"/>
                 </a:solidFill>
               </a:defRPr>
             </a:pPr>
@@ -7261,11 +7492,11 @@
             <a:avLst/>
           </a:prstGeom>
           <a:solidFill>
-            <a:srgbClr val="0F172A"/>
+            <a:srgbClr val="161B22"/>
           </a:solidFill>
           <a:ln w="12700">
             <a:solidFill>
-              <a:srgbClr val="1E293B"/>
+              <a:srgbClr val="21262D"/>
             </a:solidFill>
           </a:ln>
         </p:spPr>
@@ -7306,7 +7537,7 @@
             <a:avLst/>
           </a:prstGeom>
           <a:solidFill>
-            <a:srgbClr val="0EA5E9"/>
+            <a:srgbClr val="F59E0B"/>
           </a:solidFill>
           <a:ln>
             <a:noFill/>
@@ -7359,7 +7590,7 @@
             <a:pPr>
               <a:defRPr sz="1500" b="1">
                 <a:solidFill>
-                  <a:srgbClr val="38BDF8"/>
+                  <a:srgbClr val="34D399"/>
                 </a:solidFill>
                 <a:latin typeface="Arial"/>
               </a:defRPr>
@@ -7395,7 +7626,7 @@
             <a:pPr>
               <a:defRPr sz="1100">
                 <a:solidFill>
-                  <a:srgbClr val="F8FAFC"/>
+                  <a:srgbClr val="F0F6FC"/>
                 </a:solidFill>
               </a:defRPr>
             </a:pPr>
@@ -7420,11 +7651,11 @@
             <a:avLst/>
           </a:prstGeom>
           <a:solidFill>
-            <a:srgbClr val="0F172A"/>
+            <a:srgbClr val="161B22"/>
           </a:solidFill>
           <a:ln w="12700">
             <a:solidFill>
-              <a:srgbClr val="1E293B"/>
+              <a:srgbClr val="21262D"/>
             </a:solidFill>
           </a:ln>
         </p:spPr>
@@ -7465,7 +7696,7 @@
             <a:avLst/>
           </a:prstGeom>
           <a:solidFill>
-            <a:srgbClr val="0EA5E9"/>
+            <a:srgbClr val="F59E0B"/>
           </a:solidFill>
           <a:ln>
             <a:noFill/>
@@ -7518,7 +7749,7 @@
             <a:pPr>
               <a:defRPr sz="1500" b="1">
                 <a:solidFill>
-                  <a:srgbClr val="38BDF8"/>
+                  <a:srgbClr val="34D399"/>
                 </a:solidFill>
                 <a:latin typeface="Arial"/>
               </a:defRPr>
@@ -7554,7 +7785,7 @@
             <a:pPr>
               <a:defRPr sz="1100">
                 <a:solidFill>
-                  <a:srgbClr val="F8FAFC"/>
+                  <a:srgbClr val="F0F6FC"/>
                 </a:solidFill>
               </a:defRPr>
             </a:pPr>
@@ -7579,11 +7810,11 @@
             <a:avLst/>
           </a:prstGeom>
           <a:solidFill>
-            <a:srgbClr val="0F172A"/>
+            <a:srgbClr val="161B22"/>
           </a:solidFill>
           <a:ln w="12700">
             <a:solidFill>
-              <a:srgbClr val="1E293B"/>
+              <a:srgbClr val="21262D"/>
             </a:solidFill>
           </a:ln>
         </p:spPr>
@@ -7624,7 +7855,7 @@
             <a:avLst/>
           </a:prstGeom>
           <a:solidFill>
-            <a:srgbClr val="0EA5E9"/>
+            <a:srgbClr val="10B981"/>
           </a:solidFill>
           <a:ln>
             <a:noFill/>
@@ -7677,7 +7908,7 @@
             <a:pPr>
               <a:defRPr sz="1500" b="1">
                 <a:solidFill>
-                  <a:srgbClr val="38BDF8"/>
+                  <a:srgbClr val="34D399"/>
                 </a:solidFill>
                 <a:latin typeface="Arial"/>
               </a:defRPr>
@@ -7713,7 +7944,7 @@
             <a:pPr>
               <a:defRPr sz="1100">
                 <a:solidFill>
-                  <a:srgbClr val="F8FAFC"/>
+                  <a:srgbClr val="F0F6FC"/>
                 </a:solidFill>
               </a:defRPr>
             </a:pPr>
@@ -7748,13 +7979,13 @@
             <a:pPr>
               <a:defRPr sz="900">
                 <a:solidFill>
-                  <a:srgbClr val="94A3B8"/>
+                  <a:srgbClr val="8B949E"/>
                 </a:solidFill>
                 <a:latin typeface="Arial"/>
               </a:defRPr>
             </a:pPr>
             <a:r>
-              <a:t>AI-Based Personalized Tutor Using RAG for Syllabus-Aligned Learning  |  Slide 8 of 9</a:t>
+              <a:t>AI-Based Personalized Tutor Using RAG for Syllabus-Aligned Learning  |  Slide 8 of 10</a:t>
             </a:r>
           </a:p>
         </p:txBody>
@@ -7773,7 +8004,7 @@
     <p:bg>
       <p:bgPr>
         <a:solidFill>
-          <a:srgbClr val="0B0F17"/>
+          <a:srgbClr val="0D1117"/>
         </a:solidFill>
         <a:effectLst/>
       </p:bgPr>
@@ -7810,13 +8041,13 @@
             <a:pPr>
               <a:defRPr sz="1000" b="1">
                 <a:solidFill>
-                  <a:srgbClr val="38BDF8"/>
+                  <a:srgbClr val="34D399"/>
                 </a:solidFill>
                 <a:latin typeface="Arial"/>
               </a:defRPr>
             </a:pPr>
             <a:r>
-              <a:t>CAPSTONE PROJECT</a:t>
+              <a:t>CAPSTONE PROJECT PRESENTATION</a:t>
             </a:r>
           </a:p>
         </p:txBody>
@@ -7846,7 +8077,7 @@
             <a:pPr>
               <a:defRPr sz="2400" b="1">
                 <a:solidFill>
-                  <a:srgbClr val="F8FAFC"/>
+                  <a:srgbClr val="F0F6FC"/>
                 </a:solidFill>
                 <a:latin typeface="Arial"/>
               </a:defRPr>
@@ -7872,11 +8103,11 @@
             <a:avLst/>
           </a:prstGeom>
           <a:solidFill>
-            <a:srgbClr val="0F172A"/>
+            <a:srgbClr val="161B22"/>
           </a:solidFill>
           <a:ln w="12700">
             <a:solidFill>
-              <a:srgbClr val="1E293B"/>
+              <a:srgbClr val="21262D"/>
             </a:solidFill>
           </a:ln>
         </p:spPr>
@@ -7917,7 +8148,7 @@
             <a:avLst/>
           </a:prstGeom>
           <a:solidFill>
-            <a:srgbClr val="0EA5E9"/>
+            <a:srgbClr val="10B981"/>
           </a:solidFill>
           <a:ln>
             <a:noFill/>
@@ -7970,7 +8201,7 @@
             <a:pPr>
               <a:defRPr sz="1500" b="1">
                 <a:solidFill>
-                  <a:srgbClr val="38BDF8"/>
+                  <a:srgbClr val="34D399"/>
                 </a:solidFill>
                 <a:latin typeface="Arial"/>
               </a:defRPr>
@@ -8025,7 +8256,7 @@
                   </a:txBody>
                   <a:tcPr>
                     <a:solidFill>
-                      <a:srgbClr val="0284C7"/>
+                      <a:srgbClr val="10B981"/>
                     </a:solidFill>
                   </a:tcPr>
                 </a:tc>
@@ -8048,7 +8279,7 @@
                   </a:txBody>
                   <a:tcPr>
                     <a:solidFill>
-                      <a:srgbClr val="0284C7"/>
+                      <a:srgbClr val="10B981"/>
                     </a:solidFill>
                   </a:tcPr>
                 </a:tc>
@@ -8071,7 +8302,7 @@
                   </a:txBody>
                   <a:tcPr>
                     <a:solidFill>
-                      <a:srgbClr val="0284C7"/>
+                      <a:srgbClr val="10B981"/>
                     </a:solidFill>
                   </a:tcPr>
                 </a:tc>
@@ -8094,7 +8325,7 @@
                   </a:txBody>
                   <a:tcPr>
                     <a:solidFill>
-                      <a:srgbClr val="0284C7"/>
+                      <a:srgbClr val="10B981"/>
                     </a:solidFill>
                   </a:tcPr>
                 </a:tc>
@@ -8108,7 +8339,7 @@
                       <a:pPr>
                         <a:defRPr sz="1000">
                           <a:solidFill>
-                            <a:srgbClr val="F8FAFC"/>
+                            <a:srgbClr val="F0F6FC"/>
                           </a:solidFill>
                         </a:defRPr>
                       </a:pPr>
@@ -8119,7 +8350,7 @@
                   </a:txBody>
                   <a:tcPr>
                     <a:solidFill>
-                      <a:srgbClr val="0F172A"/>
+                      <a:srgbClr val="161B22"/>
                     </a:solidFill>
                   </a:tcPr>
                 </a:tc>
@@ -8131,7 +8362,7 @@
                       <a:pPr>
                         <a:defRPr sz="1000">
                           <a:solidFill>
-                            <a:srgbClr val="F8FAFC"/>
+                            <a:srgbClr val="F0F6FC"/>
                           </a:solidFill>
                         </a:defRPr>
                       </a:pPr>
@@ -8142,7 +8373,7 @@
                   </a:txBody>
                   <a:tcPr>
                     <a:solidFill>
-                      <a:srgbClr val="0F172A"/>
+                      <a:srgbClr val="161B22"/>
                     </a:solidFill>
                   </a:tcPr>
                 </a:tc>
@@ -8154,7 +8385,7 @@
                       <a:pPr>
                         <a:defRPr sz="1000">
                           <a:solidFill>
-                            <a:srgbClr val="F8FAFC"/>
+                            <a:srgbClr val="F0F6FC"/>
                           </a:solidFill>
                         </a:defRPr>
                       </a:pPr>
@@ -8165,7 +8396,7 @@
                   </a:txBody>
                   <a:tcPr>
                     <a:solidFill>
-                      <a:srgbClr val="0F172A"/>
+                      <a:srgbClr val="161B22"/>
                     </a:solidFill>
                   </a:tcPr>
                 </a:tc>
@@ -8177,18 +8408,18 @@
                       <a:pPr>
                         <a:defRPr sz="1000">
                           <a:solidFill>
-                            <a:srgbClr val="F8FAFC"/>
+                            <a:srgbClr val="F0F6FC"/>
                           </a:solidFill>
                         </a:defRPr>
                       </a:pPr>
                       <a:r>
-                        <a:t>Executive dark slate design system, Google Fonts (Plus Jakarta Sans &amp; Inter)</a:t>
+                        <a:t>Executive dark charcoal design system, Google Fonts (Plus Jakarta Sans &amp; Inter)</a:t>
                       </a:r>
                     </a:p>
                   </a:txBody>
                   <a:tcPr>
                     <a:solidFill>
-                      <a:srgbClr val="0F172A"/>
+                      <a:srgbClr val="161B22"/>
                     </a:solidFill>
                   </a:tcPr>
                 </a:tc>
@@ -8202,7 +8433,7 @@
                       <a:pPr>
                         <a:defRPr sz="1000">
                           <a:solidFill>
-                            <a:srgbClr val="F8FAFC"/>
+                            <a:srgbClr val="F0F6FC"/>
                           </a:solidFill>
                         </a:defRPr>
                       </a:pPr>
@@ -8213,7 +8444,7 @@
                   </a:txBody>
                   <a:tcPr>
                     <a:solidFill>
-                      <a:srgbClr val="0B0F17"/>
+                      <a:srgbClr val="0D1117"/>
                     </a:solidFill>
                   </a:tcPr>
                 </a:tc>
@@ -8225,7 +8456,7 @@
                       <a:pPr>
                         <a:defRPr sz="1000">
                           <a:solidFill>
-                            <a:srgbClr val="F8FAFC"/>
+                            <a:srgbClr val="F0F6FC"/>
                           </a:solidFill>
                         </a:defRPr>
                       </a:pPr>
@@ -8236,7 +8467,7 @@
                   </a:txBody>
                   <a:tcPr>
                     <a:solidFill>
-                      <a:srgbClr val="0B0F17"/>
+                      <a:srgbClr val="0D1117"/>
                     </a:solidFill>
                   </a:tcPr>
                 </a:tc>
@@ -8248,7 +8479,7 @@
                       <a:pPr>
                         <a:defRPr sz="1000">
                           <a:solidFill>
-                            <a:srgbClr val="F8FAFC"/>
+                            <a:srgbClr val="F0F6FC"/>
                           </a:solidFill>
                         </a:defRPr>
                       </a:pPr>
@@ -8259,7 +8490,7 @@
                   </a:txBody>
                   <a:tcPr>
                     <a:solidFill>
-                      <a:srgbClr val="0B0F17"/>
+                      <a:srgbClr val="0D1117"/>
                     </a:solidFill>
                   </a:tcPr>
                 </a:tc>
@@ -8271,7 +8502,7 @@
                       <a:pPr>
                         <a:defRPr sz="1000">
                           <a:solidFill>
-                            <a:srgbClr val="F8FAFC"/>
+                            <a:srgbClr val="F0F6FC"/>
                           </a:solidFill>
                         </a:defRPr>
                       </a:pPr>
@@ -8282,7 +8513,7 @@
                   </a:txBody>
                   <a:tcPr>
                     <a:solidFill>
-                      <a:srgbClr val="0B0F17"/>
+                      <a:srgbClr val="0D1117"/>
                     </a:solidFill>
                   </a:tcPr>
                 </a:tc>
@@ -8296,7 +8527,7 @@
                       <a:pPr>
                         <a:defRPr sz="1000">
                           <a:solidFill>
-                            <a:srgbClr val="F8FAFC"/>
+                            <a:srgbClr val="F0F6FC"/>
                           </a:solidFill>
                         </a:defRPr>
                       </a:pPr>
@@ -8307,7 +8538,7 @@
                   </a:txBody>
                   <a:tcPr>
                     <a:solidFill>
-                      <a:srgbClr val="0F172A"/>
+                      <a:srgbClr val="161B22"/>
                     </a:solidFill>
                   </a:tcPr>
                 </a:tc>
@@ -8319,7 +8550,7 @@
                       <a:pPr>
                         <a:defRPr sz="1000">
                           <a:solidFill>
-                            <a:srgbClr val="F8FAFC"/>
+                            <a:srgbClr val="F0F6FC"/>
                           </a:solidFill>
                         </a:defRPr>
                       </a:pPr>
@@ -8330,7 +8561,7 @@
                   </a:txBody>
                   <a:tcPr>
                     <a:solidFill>
-                      <a:srgbClr val="0F172A"/>
+                      <a:srgbClr val="161B22"/>
                     </a:solidFill>
                   </a:tcPr>
                 </a:tc>
@@ -8342,7 +8573,7 @@
                       <a:pPr>
                         <a:defRPr sz="1000">
                           <a:solidFill>
-                            <a:srgbClr val="F8FAFC"/>
+                            <a:srgbClr val="F0F6FC"/>
                           </a:solidFill>
                         </a:defRPr>
                       </a:pPr>
@@ -8353,7 +8584,7 @@
                   </a:txBody>
                   <a:tcPr>
                     <a:solidFill>
-                      <a:srgbClr val="0F172A"/>
+                      <a:srgbClr val="161B22"/>
                     </a:solidFill>
                   </a:tcPr>
                 </a:tc>
@@ -8365,7 +8596,7 @@
                       <a:pPr>
                         <a:defRPr sz="1000">
                           <a:solidFill>
-                            <a:srgbClr val="F8FAFC"/>
+                            <a:srgbClr val="F0F6FC"/>
                           </a:solidFill>
                         </a:defRPr>
                       </a:pPr>
@@ -8376,7 +8607,7 @@
                   </a:txBody>
                   <a:tcPr>
                     <a:solidFill>
-                      <a:srgbClr val="0F172A"/>
+                      <a:srgbClr val="161B22"/>
                     </a:solidFill>
                   </a:tcPr>
                 </a:tc>
@@ -8390,7 +8621,7 @@
                       <a:pPr>
                         <a:defRPr sz="1000">
                           <a:solidFill>
-                            <a:srgbClr val="F8FAFC"/>
+                            <a:srgbClr val="F0F6FC"/>
                           </a:solidFill>
                         </a:defRPr>
                       </a:pPr>
@@ -8401,7 +8632,7 @@
                   </a:txBody>
                   <a:tcPr>
                     <a:solidFill>
-                      <a:srgbClr val="0B0F17"/>
+                      <a:srgbClr val="0D1117"/>
                     </a:solidFill>
                   </a:tcPr>
                 </a:tc>
@@ -8413,7 +8644,7 @@
                       <a:pPr>
                         <a:defRPr sz="1000">
                           <a:solidFill>
-                            <a:srgbClr val="F8FAFC"/>
+                            <a:srgbClr val="F0F6FC"/>
                           </a:solidFill>
                         </a:defRPr>
                       </a:pPr>
@@ -8424,7 +8655,7 @@
                   </a:txBody>
                   <a:tcPr>
                     <a:solidFill>
-                      <a:srgbClr val="0B0F17"/>
+                      <a:srgbClr val="0D1117"/>
                     </a:solidFill>
                   </a:tcPr>
                 </a:tc>
@@ -8436,7 +8667,7 @@
                       <a:pPr>
                         <a:defRPr sz="1000">
                           <a:solidFill>
-                            <a:srgbClr val="F8FAFC"/>
+                            <a:srgbClr val="F0F6FC"/>
                           </a:solidFill>
                         </a:defRPr>
                       </a:pPr>
@@ -8447,7 +8678,7 @@
                   </a:txBody>
                   <a:tcPr>
                     <a:solidFill>
-                      <a:srgbClr val="0B0F17"/>
+                      <a:srgbClr val="0D1117"/>
                     </a:solidFill>
                   </a:tcPr>
                 </a:tc>
@@ -8459,7 +8690,7 @@
                       <a:pPr>
                         <a:defRPr sz="1000">
                           <a:solidFill>
-                            <a:srgbClr val="F8FAFC"/>
+                            <a:srgbClr val="F0F6FC"/>
                           </a:solidFill>
                         </a:defRPr>
                       </a:pPr>
@@ -8470,7 +8701,7 @@
                   </a:txBody>
                   <a:tcPr>
                     <a:solidFill>
-                      <a:srgbClr val="0B0F17"/>
+                      <a:srgbClr val="0D1117"/>
                     </a:solidFill>
                   </a:tcPr>
                 </a:tc>
@@ -8504,13 +8735,13 @@
             <a:pPr>
               <a:defRPr sz="900">
                 <a:solidFill>
-                  <a:srgbClr val="94A3B8"/>
+                  <a:srgbClr val="8B949E"/>
                 </a:solidFill>
                 <a:latin typeface="Arial"/>
               </a:defRPr>
             </a:pPr>
             <a:r>
-              <a:t>AI-Based Personalized Tutor Using RAG for Syllabus-Aligned Learning  |  Slide 9 of 9</a:t>
+              <a:t>AI-Based Personalized Tutor Using RAG for Syllabus-Aligned Learning  |  Slide 9 of 10</a:t>
             </a:r>
           </a:p>
         </p:txBody>

</xml_diff>